<commit_message>
update Thu 07/09/2026  1:37:06.83
</commit_message>
<xml_diff>
--- a/courses/course-01-intro-to-ai/slides/Cambium-Academy-Course01-Intro-to-AI.pptx
+++ b/courses/course-01-intro-to-ai/slides/Cambium-Academy-Course01-Intro-to-AI.pptx
@@ -3089,7 +3089,7 @@
           <a:p>
             <a:r>
               <a:rPr lang="en-US" dirty="0"/>
-              <a:t>That is the course. You now understand AI better than most people using it daily. The quiz link is on the course page, twenty questions, pass at seventy percent, and your certificate prints on the spot. Next week, course two, Prompting Essentials. I will see you there.</a:t>
+              <a:t>That is the lecture, step one of your path, done. Two short steps remain before the quiz unlocks: clear all twenty-four flashcards, and explore the three stations in the AI Lab. Then the quiz opens: twenty questions, fourteen to pass, and your certificate prints on the spot, ready for LinkedIn. Next week, Course 2, Prompting Essentials. I will see you there.</a:t>
             </a:r>
             <a:endParaRPr lang="en-US" dirty="0"/>
           </a:p>
@@ -3177,7 +3177,7 @@
           <a:p>
             <a:r>
               <a:rPr lang="en-US" dirty="0"/>
-              <a:t>The route we will take. Six short modules, about an hour of content. Then a twenty question quiz. Pass at seventy percent and you print your certificate immediately. No account, no email, no payment.</a:t>
+              <a:t>The route we will take. Six short modules, about an hour. Watching this lecture is step one of your path. After it, the flashcards and the hands-on AI Lab unlock the quiz. Pass at seventy percent and your certificate prints immediately. No account, no email, no payment.</a:t>
             </a:r>
             <a:endParaRPr lang="en-US" dirty="0"/>
           </a:p>
@@ -22781,8 +22781,8 @@
         </p:nvSpPr>
         <p:spPr>
           <a:xfrm>
-            <a:off x="548640" y="1417320"/>
-            <a:ext cx="8046720" cy="1280160"/>
+            <a:off x="548640" y="1371600"/>
+            <a:ext cx="8046720" cy="1188720"/>
           </a:xfrm>
           <a:prstGeom prst="rect">
             <a:avLst/>
@@ -22798,7 +22798,7 @@
               <a:buNone/>
             </a:pPr>
             <a:r>
-              <a:rPr lang="en-US" sz="3800" b="1" dirty="0">
+              <a:rPr lang="en-US" sz="3700" b="1" dirty="0">
                 <a:solidFill>
                   <a:srgbClr val="FFFFFF"/>
                 </a:solidFill>
@@ -22806,9 +22806,9 @@
                 <a:ea typeface="Cambria" pitchFamily="34" charset="-122"/>
                 <a:cs typeface="Cambria" pitchFamily="34" charset="-120"/>
               </a:rPr>
-              <a:t>Take the quiz. Earn your certificate.</a:t>
-            </a:r>
-            <a:endParaRPr lang="en-US" sz="3800" dirty="0"/>
+              <a:t>Finish the path. Earn your certificate.</a:t>
+            </a:r>
+            <a:endParaRPr lang="en-US" sz="3700" dirty="0"/>
           </a:p>
         </p:txBody>
       </p:sp>
@@ -22820,8 +22820,8 @@
         </p:nvSpPr>
         <p:spPr>
           <a:xfrm>
-            <a:off x="548640" y="2651760"/>
-            <a:ext cx="402336" cy="402336"/>
+            <a:off x="548640" y="2487168"/>
+            <a:ext cx="384048" cy="384048"/>
           </a:xfrm>
           <a:prstGeom prst="ellipse">
             <a:avLst/>
@@ -22848,8 +22848,8 @@
         </p:blipFill>
         <p:spPr>
           <a:xfrm>
-            <a:off x="653247" y="2756367"/>
-            <a:ext cx="193121" cy="193121"/>
+            <a:off x="648492" y="2587020"/>
+            <a:ext cx="184343" cy="184343"/>
           </a:xfrm>
           <a:prstGeom prst="rect">
             <a:avLst/>
@@ -22864,8 +22864,8 @@
         </p:nvSpPr>
         <p:spPr>
           <a:xfrm>
-            <a:off x="1143000" y="2697480"/>
-            <a:ext cx="6858000" cy="365760"/>
+            <a:off x="1097280" y="2523744"/>
+            <a:ext cx="7406640" cy="365760"/>
           </a:xfrm>
           <a:prstGeom prst="rect">
             <a:avLst/>
@@ -22881,7 +22881,7 @@
               <a:buNone/>
             </a:pPr>
             <a:r>
-              <a:rPr lang="en-US" sz="1400" dirty="0">
+              <a:rPr lang="en-US" sz="1350" dirty="0">
                 <a:solidFill>
                   <a:srgbClr val="E8F2DE"/>
                 </a:solidFill>
@@ -22889,9 +22889,9 @@
                 <a:ea typeface="Calibri" pitchFamily="34" charset="-122"/>
                 <a:cs typeface="Calibri" pitchFamily="34" charset="-120"/>
               </a:rPr>
-              <a:t>20 questions, all covered in these slides</a:t>
-            </a:r>
-            <a:endParaRPr lang="en-US" sz="1400" dirty="0"/>
+              <a:t>Step 1, the lecture: done, you just finished it</a:t>
+            </a:r>
+            <a:endParaRPr lang="en-US" sz="1350" dirty="0"/>
           </a:p>
         </p:txBody>
       </p:sp>
@@ -22903,8 +22903,8 @@
         </p:nvSpPr>
         <p:spPr>
           <a:xfrm>
-            <a:off x="548640" y="3218688"/>
-            <a:ext cx="402336" cy="402336"/>
+            <a:off x="548640" y="2999232"/>
+            <a:ext cx="384048" cy="384048"/>
           </a:xfrm>
           <a:prstGeom prst="ellipse">
             <a:avLst/>
@@ -22931,8 +22931,8 @@
         </p:blipFill>
         <p:spPr>
           <a:xfrm>
-            <a:off x="653247" y="3323295"/>
-            <a:ext cx="193121" cy="193121"/>
+            <a:off x="648492" y="3099084"/>
+            <a:ext cx="184343" cy="184343"/>
           </a:xfrm>
           <a:prstGeom prst="rect">
             <a:avLst/>
@@ -22947,8 +22947,8 @@
         </p:nvSpPr>
         <p:spPr>
           <a:xfrm>
-            <a:off x="1143000" y="3264408"/>
-            <a:ext cx="6858000" cy="365760"/>
+            <a:off x="1097280" y="3035808"/>
+            <a:ext cx="7406640" cy="365760"/>
           </a:xfrm>
           <a:prstGeom prst="rect">
             <a:avLst/>
@@ -22964,7 +22964,7 @@
               <a:buNone/>
             </a:pPr>
             <a:r>
-              <a:rPr lang="en-US" sz="1400" dirty="0">
+              <a:rPr lang="en-US" sz="1350" dirty="0">
                 <a:solidFill>
                   <a:srgbClr val="E8F2DE"/>
                 </a:solidFill>
@@ -22972,9 +22972,9 @@
                 <a:ea typeface="Calibri" pitchFamily="34" charset="-122"/>
                 <a:cs typeface="Calibri" pitchFamily="34" charset="-120"/>
               </a:rPr>
-              <a:t>Score 70% or better to pass</a:t>
-            </a:r>
-            <a:endParaRPr lang="en-US" sz="1400" dirty="0"/>
+              <a:t>Step 2: clear all 24 flashcards until they stick</a:t>
+            </a:r>
+            <a:endParaRPr lang="en-US" sz="1350" dirty="0"/>
           </a:p>
         </p:txBody>
       </p:sp>
@@ -22986,8 +22986,8 @@
         </p:nvSpPr>
         <p:spPr>
           <a:xfrm>
-            <a:off x="548640" y="3785616"/>
-            <a:ext cx="402336" cy="402336"/>
+            <a:off x="548640" y="3511296"/>
+            <a:ext cx="384048" cy="384048"/>
           </a:xfrm>
           <a:prstGeom prst="ellipse">
             <a:avLst/>
@@ -23014,8 +23014,8 @@
         </p:blipFill>
         <p:spPr>
           <a:xfrm>
-            <a:off x="653247" y="3890223"/>
-            <a:ext cx="193121" cy="193121"/>
+            <a:off x="648492" y="3611148"/>
+            <a:ext cx="184343" cy="184343"/>
           </a:xfrm>
           <a:prstGeom prst="rect">
             <a:avLst/>
@@ -23030,8 +23030,8 @@
         </p:nvSpPr>
         <p:spPr>
           <a:xfrm>
-            <a:off x="1143000" y="3831336"/>
-            <a:ext cx="6858000" cy="365760"/>
+            <a:off x="1097280" y="3547872"/>
+            <a:ext cx="7406640" cy="365760"/>
           </a:xfrm>
           <a:prstGeom prst="rect">
             <a:avLst/>
@@ -23047,7 +23047,7 @@
               <a:buNone/>
             </a:pPr>
             <a:r>
-              <a:rPr lang="en-US" sz="1400" dirty="0">
+              <a:rPr lang="en-US" sz="1350" dirty="0">
                 <a:solidFill>
                   <a:srgbClr val="E8F2DE"/>
                 </a:solidFill>
@@ -23055,15 +23055,98 @@
                 <a:ea typeface="Calibri" pitchFamily="34" charset="-122"/>
                 <a:cs typeface="Calibri" pitchFamily="34" charset="-120"/>
               </a:rPr>
-              <a:t>Print your Cambium Academy certificate on the spot</a:t>
-            </a:r>
-            <a:endParaRPr lang="en-US" sz="1400" dirty="0"/>
-          </a:p>
-        </p:txBody>
-      </p:sp>
-      <p:sp>
-        <p:nvSpPr>
-          <p:cNvPr id="15" name="Text 9"/>
+              <a:t>Step 3: explore the three stations in the AI Lab</a:t>
+            </a:r>
+            <a:endParaRPr lang="en-US" sz="1350" dirty="0"/>
+          </a:p>
+        </p:txBody>
+      </p:sp>
+      <p:sp>
+        <p:nvSpPr>
+          <p:cNvPr id="15" name="Shape 9"/>
+          <p:cNvSpPr/>
+          <p:nvPr/>
+        </p:nvSpPr>
+        <p:spPr>
+          <a:xfrm>
+            <a:off x="548640" y="4023360"/>
+            <a:ext cx="384048" cy="384048"/>
+          </a:xfrm>
+          <a:prstGeom prst="ellipse">
+            <a:avLst/>
+          </a:prstGeom>
+          <a:solidFill>
+            <a:srgbClr val="2C5F2D"/>
+          </a:solidFill>
+          <a:ln/>
+        </p:spPr>
+      </p:sp>
+      <p:pic>
+        <p:nvPicPr>
+          <p:cNvPr id="16" name="Image 4" descr="preencoded.png">    </p:cNvPr>
+          <p:cNvPicPr>
+            <a:picLocks noChangeAspect="1"/>
+          </p:cNvPicPr>
+          <p:nvPr/>
+        </p:nvPicPr>
+        <p:blipFill>
+          <a:blip r:embed="rId5"/>
+          <a:stretch>
+            <a:fillRect/>
+          </a:stretch>
+        </p:blipFill>
+        <p:spPr>
+          <a:xfrm>
+            <a:off x="648492" y="4123212"/>
+            <a:ext cx="184343" cy="184343"/>
+          </a:xfrm>
+          <a:prstGeom prst="rect">
+            <a:avLst/>
+          </a:prstGeom>
+        </p:spPr>
+      </p:pic>
+      <p:sp>
+        <p:nvSpPr>
+          <p:cNvPr id="17" name="Text 10"/>
+          <p:cNvSpPr/>
+          <p:nvPr/>
+        </p:nvSpPr>
+        <p:spPr>
+          <a:xfrm>
+            <a:off x="1097280" y="4059936"/>
+            <a:ext cx="7406640" cy="365760"/>
+          </a:xfrm>
+          <a:prstGeom prst="rect">
+            <a:avLst/>
+          </a:prstGeom>
+          <a:noFill/>
+          <a:ln/>
+        </p:spPr>
+        <p:txBody>
+          <a:bodyPr wrap="square" lIns="0" tIns="0" rIns="0" bIns="0" rtlCol="0" anchor="ctr"/>
+          <a:lstStyle/>
+          <a:p>
+            <a:pPr indent="0" marL="0">
+              <a:buNone/>
+            </a:pPr>
+            <a:r>
+              <a:rPr lang="en-US" sz="1350" dirty="0">
+                <a:solidFill>
+                  <a:srgbClr val="E8F2DE"/>
+                </a:solidFill>
+                <a:latin typeface="Calibri" pitchFamily="34" charset="0"/>
+                <a:ea typeface="Calibri" pitchFamily="34" charset="-122"/>
+                <a:cs typeface="Calibri" pitchFamily="34" charset="-120"/>
+              </a:rPr>
+              <a:t>The quiz unlocks: 20 questions, 70% to pass, certificate prints on the spot</a:t>
+            </a:r>
+            <a:endParaRPr lang="en-US" sz="1350" dirty="0"/>
+          </a:p>
+        </p:txBody>
+      </p:sp>
+      <p:sp>
+        <p:nvSpPr>
+          <p:cNvPr id="18" name="Text 11"/>
           <p:cNvSpPr/>
           <p:nvPr/>
         </p:nvSpPr>
@@ -24180,7 +24263,7 @@
                 <a:ea typeface="Calibri" pitchFamily="34" charset="-122"/>
                 <a:cs typeface="Calibri" pitchFamily="34" charset="-120"/>
               </a:rPr>
-              <a:t>a 20 question quiz. Score 70% or better and print your certificate on the spot.</a:t>
+              <a:t>flashcards and the hands-on AI Lab unlock the 20-question quiz. Score 70% or better and print your certificate on the spot.</a:t>
             </a:r>
             <a:endParaRPr lang="en-US" sz="1250" dirty="0"/>
           </a:p>

</xml_diff>